<commit_message>
polish: dashboard fixes + Ch1 live narratives + pitch script v3 + deck refresh
- dashboard/app.py: keep sidebar toggle clickable (pointer-events trick + z-index)
- dashboard/tabs/ch1_map.py: replace hardcoded MM1 / Unley / OECD narratives with
  live-computed values from df_yr / mmm_q / state_acc / supply (no-hardcode rule)
- slides_deck/Australias-Aged-Care-Gap.pptx: S6/S7/S8/S10/S11 numbers aligned with
  refreshed dashboard data (2026-05-13)
- slides_deck/pitch_script.html: v3 full-English rehearsal companion — 11 slides,
  4-layer cards (Sees / Meaning / Says / Pacing), QR-invite S9 (no live demo),
  ~4:30 target, Q&A backpocket + rehearsal protocol + pre-pitch checklist

Co-Authored-By: Claude Opus 4.7 <noreply@anthropic.com>
</commit_message>
<xml_diff>
--- a/slides_deck/Australias-Aged-Care-Gap.pptx
+++ b/slides_deck/Australias-Aged-Care-Gap.pptx
@@ -5,7 +5,7 @@
     <p:sldMasterId id="2147483650" r:id="rId1"/>
   </p:sldMasterIdLst>
   <p:notesMasterIdLst>
-    <p:notesMasterId r:id="rId13"/>
+    <p:notesMasterId r:id="rId14"/>
   </p:notesMasterIdLst>
   <p:sldIdLst>
     <p:sldId id="270" r:id="rId2"/>
@@ -16,9 +16,10 @@
     <p:sldId id="287" r:id="rId7"/>
     <p:sldId id="291" r:id="rId8"/>
     <p:sldId id="299" r:id="rId9"/>
-    <p:sldId id="293" r:id="rId10"/>
+    <p:sldId id="303" r:id="rId10"/>
     <p:sldId id="279" r:id="rId11"/>
     <p:sldId id="294" r:id="rId12"/>
+    <p:sldId id="302" r:id="rId13"/>
   </p:sldIdLst>
   <p:sldSz cx="12192000" cy="6858000"/>
   <p:notesSz cx="6858000" cy="12192000"/>
@@ -868,6 +869,160 @@
         <c:barDir val="bar"/>
         <c:grouping val="clustered"/>
         <c:varyColors val="0"/>
+        <c:dLbls>
+          <c:showLegendKey val="0"/>
+          <c:showVal val="1"/>
+          <c:showCatName val="0"/>
+          <c:showSerName val="0"/>
+          <c:showPercent val="0"/>
+          <c:showBubbleSize val="0"/>
+        </c:dLbls>
+        <c:gapWidth val="30"/>
+        <c:axId val="2094734554"/>
+        <c:axId val="2094734552"/>
+      </c:barChart>
+      <c:catAx>
+        <c:axId val="2094734554"/>
+        <c:scaling>
+          <c:orientation val="minMax"/>
+        </c:scaling>
+        <c:delete val="0"/>
+        <c:axPos val="l"/>
+        <c:numFmt formatCode="General" sourceLinked="1"/>
+        <c:majorTickMark val="out"/>
+        <c:minorTickMark val="none"/>
+        <c:tickLblPos val="nextTo"/>
+        <c:spPr>
+          <a:ln w="12700" cap="flat">
+            <a:solidFill>
+              <a:srgbClr val="888888"/>
+            </a:solidFill>
+            <a:prstDash val="solid"/>
+            <a:round/>
+          </a:ln>
+        </c:spPr>
+        <c:txPr>
+          <a:bodyPr/>
+          <a:lstStyle/>
+          <a:p>
+            <a:pPr>
+              <a:defRPr sz="1000" b="0" i="0" u="none" strike="noStrike">
+                <a:solidFill>
+                  <a:srgbClr val="11304E"/>
+                </a:solidFill>
+                <a:latin typeface="Arial"/>
+              </a:defRPr>
+            </a:pPr>
+            <a:endParaRPr lang="en-US"/>
+          </a:p>
+        </c:txPr>
+        <c:crossAx val="2094734552"/>
+        <c:crosses val="autoZero"/>
+        <c:auto val="1"/>
+        <c:lblAlgn val="ctr"/>
+        <c:lblOffset val="100"/>
+        <c:noMultiLvlLbl val="1"/>
+      </c:catAx>
+      <c:valAx>
+        <c:axId val="2094734552"/>
+        <c:scaling>
+          <c:orientation val="minMax"/>
+          <c:max val="3.5"/>
+          <c:min val="0"/>
+        </c:scaling>
+        <c:delete val="0"/>
+        <c:axPos val="b"/>
+        <c:majorGridlines>
+          <c:spPr>
+            <a:ln w="6350" cap="flat">
+              <a:solidFill>
+                <a:srgbClr val="E8E2D2"/>
+              </a:solidFill>
+              <a:prstDash val="solid"/>
+              <a:round/>
+            </a:ln>
+          </c:spPr>
+        </c:majorGridlines>
+        <c:numFmt formatCode="General" sourceLinked="0"/>
+        <c:majorTickMark val="out"/>
+        <c:minorTickMark val="none"/>
+        <c:tickLblPos val="low"/>
+        <c:spPr>
+          <a:ln w="12700" cap="flat">
+            <a:solidFill>
+              <a:srgbClr val="888888"/>
+            </a:solidFill>
+            <a:prstDash val="solid"/>
+            <a:round/>
+          </a:ln>
+        </c:spPr>
+        <c:txPr>
+          <a:bodyPr/>
+          <a:lstStyle/>
+          <a:p>
+            <a:pPr>
+              <a:defRPr sz="900" b="0" i="0" u="none" strike="noStrike">
+                <a:solidFill>
+                  <a:srgbClr val="4A5A6E"/>
+                </a:solidFill>
+                <a:latin typeface="Arial"/>
+              </a:defRPr>
+            </a:pPr>
+            <a:endParaRPr lang="en-US"/>
+          </a:p>
+        </c:txPr>
+        <c:crossAx val="2094734554"/>
+        <c:crosses val="autoZero"/>
+        <c:crossBetween val="between"/>
+      </c:valAx>
+      <c:spPr>
+        <a:noFill/>
+        <a:ln>
+          <a:noFill/>
+        </a:ln>
+        <a:effectLst/>
+      </c:spPr>
+    </c:plotArea>
+    <c:plotVisOnly val="1"/>
+    <c:dispBlanksAs val="span"/>
+    <c:showDLblsOverMax val="1"/>
+  </c:chart>
+  <c:spPr>
+    <a:solidFill>
+      <a:srgbClr val="FFFFFF"/>
+    </a:solidFill>
+    <a:ln>
+      <a:noFill/>
+    </a:ln>
+    <a:effectLst/>
+  </c:spPr>
+  <c:externalData r:id="rId1">
+    <c:autoUpdate val="0"/>
+  </c:externalData>
+</c:chartSpace>
+</file>
+
+<file path=ppt/charts/chart4.xml><?xml version="1.0" encoding="utf-8"?>
+<c:chartSpace xmlns:c="http://schemas.openxmlformats.org/drawingml/2006/chart" xmlns:a="http://schemas.openxmlformats.org/drawingml/2006/main" xmlns:r="http://schemas.openxmlformats.org/officeDocument/2006/relationships" xmlns:c16r2="http://schemas.microsoft.com/office/drawing/2015/06/chart">
+  <c:date1904 val="0"/>
+  <c:lang val="en-US"/>
+  <c:roundedCorners val="1"/>
+  <mc:AlternateContent xmlns:mc="http://schemas.openxmlformats.org/markup-compatibility/2006">
+    <mc:Choice xmlns:c14="http://schemas.microsoft.com/office/drawing/2007/8/2/chart" Requires="c14">
+      <c14:style val="102"/>
+    </mc:Choice>
+    <mc:Fallback>
+      <c:style val="2"/>
+    </mc:Fallback>
+  </mc:AlternateContent>
+  <c:chart>
+    <c:autoTitleDeleted val="1"/>
+    <c:plotArea>
+      <c:layout/>
+      <c:barChart>
+        <c:barDir val="bar"/>
+        <c:grouping val="clustered"/>
+        <c:varyColors val="0"/>
         <c:ser>
           <c:idx val="0"/>
           <c:order val="0"/>
@@ -1005,7 +1160,7 @@
           </c:val>
           <c:extLst>
             <c:ext xmlns:c16="http://schemas.microsoft.com/office/drawing/2014/chart" uri="{C3380CC4-5D6E-409C-BE32-E72D297353CC}">
-              <c16:uniqueId val="{00000000-F912-4F72-B118-95668AD748C4}"/>
+              <c16:uniqueId val="{00000000-2CEC-4AD9-AF5C-1B04B45DB832}"/>
             </c:ext>
           </c:extLst>
         </c:ser>
@@ -1142,7 +1297,7 @@
 </c:chartSpace>
 </file>
 
-<file path=ppt/charts/chart4.xml><?xml version="1.0" encoding="utf-8"?>
+<file path=ppt/charts/chart5.xml><?xml version="1.0" encoding="utf-8"?>
 <c:chartSpace xmlns:c="http://schemas.openxmlformats.org/drawingml/2006/chart" xmlns:a="http://schemas.openxmlformats.org/drawingml/2006/main" xmlns:r="http://schemas.openxmlformats.org/officeDocument/2006/relationships" xmlns:c16r2="http://schemas.microsoft.com/office/drawing/2015/06/chart">
   <c:date1904 val="0"/>
   <c:lang val="en-US"/>
@@ -2993,7 +3148,16 @@
                 </a:solidFill>
                 <a:latin typeface="Inter"/>
               </a:rPr>
-              <a:t>AUSTRALIA  ·  AGED CARE  ·  2024</a:t>
+              <a:t>AUSTRALIA  ·  AGED CARE  ·  </a:t>
+            </a:r>
+            <a:r>
+              <a:rPr lang="vi-VN" sz="1100" b="1" kern="0" spc="400" dirty="0">
+                <a:solidFill>
+                  <a:srgbClr val="4A5A6E"/>
+                </a:solidFill>
+                <a:latin typeface="Inter"/>
+              </a:rPr>
+              <a:t>2025</a:t>
             </a:r>
             <a:endParaRPr lang="en-US" sz="1100" dirty="0"/>
           </a:p>
@@ -6004,6 +6168,464 @@
     <p:extLst>
       <p:ext uri="{BB962C8B-B14F-4D97-AF65-F5344CB8AC3E}">
         <p14:creationId xmlns:p14="http://schemas.microsoft.com/office/powerpoint/2010/main" val="3658023867"/>
+      </p:ext>
+    </p:extLst>
+  </p:cSld>
+  <p:clrMapOvr>
+    <a:masterClrMapping/>
+  </p:clrMapOvr>
+</p:sld>
+</file>
+
+<file path=ppt/slides/slide12.xml><?xml version="1.0" encoding="utf-8"?>
+<p:sld xmlns:a="http://schemas.openxmlformats.org/drawingml/2006/main" xmlns:r="http://schemas.openxmlformats.org/officeDocument/2006/relationships" xmlns:p="http://schemas.openxmlformats.org/presentationml/2006/main">
+  <p:cSld>
+    <p:bg>
+      <p:bgPr>
+        <a:solidFill>
+          <a:srgbClr val="FAF7F2">
+            <a:alpha val="100000"/>
+          </a:srgbClr>
+        </a:solidFill>
+        <a:effectLst/>
+      </p:bgPr>
+    </p:bg>
+    <p:spTree>
+      <p:nvGrpSpPr>
+        <p:cNvPr id="1" name=""/>
+        <p:cNvGrpSpPr/>
+        <p:nvPr/>
+      </p:nvGrpSpPr>
+      <p:grpSpPr>
+        <a:xfrm>
+          <a:off x="0" y="0"/>
+          <a:ext cx="0" cy="0"/>
+          <a:chOff x="0" y="0"/>
+          <a:chExt cx="0" cy="0"/>
+        </a:xfrm>
+      </p:grpSpPr>
+      <p:sp>
+        <p:nvSpPr>
+          <p:cNvPr id="16" name="Rectangle 15">
+            <a:extLst>
+              <a:ext uri="{FF2B5EF4-FFF2-40B4-BE49-F238E27FC236}">
+                <a16:creationId xmlns:a16="http://schemas.microsoft.com/office/drawing/2014/main" id="{2EF02614-7C11-43EA-B1AB-8B9B26E92C63}"/>
+              </a:ext>
+            </a:extLst>
+          </p:cNvPr>
+          <p:cNvSpPr/>
+          <p:nvPr/>
+        </p:nvSpPr>
+        <p:spPr>
+          <a:xfrm>
+            <a:off x="609600" y="279400"/>
+            <a:ext cx="406400" cy="25400"/>
+          </a:xfrm>
+          <a:prstGeom prst="rect">
+            <a:avLst/>
+          </a:prstGeom>
+          <a:solidFill>
+            <a:srgbClr val="2BA39B"/>
+          </a:solidFill>
+          <a:ln w="12700" cap="flat" cmpd="sng" algn="ctr">
+            <a:noFill/>
+            <a:prstDash val="solid"/>
+            <a:miter lim="800000"/>
+          </a:ln>
+        </p:spPr>
+        <p:style>
+          <a:lnRef idx="2">
+            <a:schemeClr val="accent1">
+              <a:shade val="15000"/>
+            </a:schemeClr>
+          </a:lnRef>
+          <a:fillRef idx="1">
+            <a:schemeClr val="accent1"/>
+          </a:fillRef>
+          <a:effectRef idx="0">
+            <a:schemeClr val="accent1"/>
+          </a:effectRef>
+          <a:fontRef idx="minor">
+            <a:schemeClr val="lt1"/>
+          </a:fontRef>
+        </p:style>
+        <p:txBody>
+          <a:bodyPr vertOverflow="clip" horzOverflow="clip" rtlCol="0" anchor="t"/>
+          <a:lstStyle/>
+          <a:p>
+            <a:pPr algn="l"/>
+            <a:endParaRPr lang="en-AU"/>
+          </a:p>
+        </p:txBody>
+      </p:sp>
+      <p:sp>
+        <p:nvSpPr>
+          <p:cNvPr id="17" name="TextBox 16">
+            <a:extLst>
+              <a:ext uri="{FF2B5EF4-FFF2-40B4-BE49-F238E27FC236}">
+                <a16:creationId xmlns:a16="http://schemas.microsoft.com/office/drawing/2014/main" id="{78C7D89F-EF25-405C-A23A-2D3DE30ED363}"/>
+              </a:ext>
+            </a:extLst>
+          </p:cNvPr>
+          <p:cNvSpPr txBox="1"/>
+          <p:nvPr/>
+        </p:nvSpPr>
+        <p:spPr>
+          <a:xfrm>
+            <a:off x="1117600" y="177800"/>
+            <a:ext cx="6858000" cy="246221"/>
+          </a:xfrm>
+          <a:prstGeom prst="rect">
+            <a:avLst/>
+          </a:prstGeom>
+          <a:noFill/>
+        </p:spPr>
+        <p:txBody>
+          <a:bodyPr vertOverflow="overflow" vert="horz" wrap="square" rtlCol="0" anchor="t">
+            <a:spAutoFit/>
+          </a:bodyPr>
+          <a:lstStyle/>
+          <a:p>
+            <a:pPr marL="0" indent="0">
+              <a:buNone/>
+            </a:pPr>
+            <a:r>
+              <a:rPr lang="en-AU" sz="1000" b="1" kern="0" spc="200" dirty="0">
+                <a:solidFill>
+                  <a:srgbClr val="4A5A6E"/>
+                </a:solidFill>
+                <a:latin typeface="Inter"/>
+              </a:rPr>
+              <a:t>CLOSING · THANK YOU</a:t>
+            </a:r>
+          </a:p>
+        </p:txBody>
+      </p:sp>
+      <p:sp>
+        <p:nvSpPr>
+          <p:cNvPr id="18" name="TextBox 17">
+            <a:extLst>
+              <a:ext uri="{FF2B5EF4-FFF2-40B4-BE49-F238E27FC236}">
+                <a16:creationId xmlns:a16="http://schemas.microsoft.com/office/drawing/2014/main" id="{946E179D-A0D4-4C89-8D76-618131555A6C}"/>
+              </a:ext>
+            </a:extLst>
+          </p:cNvPr>
+          <p:cNvSpPr txBox="1"/>
+          <p:nvPr/>
+        </p:nvSpPr>
+        <p:spPr>
+          <a:xfrm>
+            <a:off x="10210800" y="177800"/>
+            <a:ext cx="1371600" cy="261610"/>
+          </a:xfrm>
+          <a:prstGeom prst="rect">
+            <a:avLst/>
+          </a:prstGeom>
+          <a:noFill/>
+        </p:spPr>
+        <p:txBody>
+          <a:bodyPr vertOverflow="overflow" vert="horz" wrap="square" rtlCol="0" anchor="t">
+            <a:spAutoFit/>
+          </a:bodyPr>
+          <a:lstStyle/>
+          <a:p>
+            <a:pPr marL="0" indent="0" algn="r">
+              <a:buNone/>
+            </a:pPr>
+            <a:r>
+              <a:rPr lang="en-AU" sz="1100" b="1" kern="0" spc="200" dirty="0">
+                <a:solidFill>
+                  <a:srgbClr val="11304E"/>
+                </a:solidFill>
+                <a:latin typeface="Inter"/>
+              </a:rPr>
+              <a:t>12 / 12</a:t>
+            </a:r>
+          </a:p>
+        </p:txBody>
+      </p:sp>
+      <p:sp>
+        <p:nvSpPr>
+          <p:cNvPr id="19" name="TextBox 18">
+            <a:extLst>
+              <a:ext uri="{FF2B5EF4-FFF2-40B4-BE49-F238E27FC236}">
+                <a16:creationId xmlns:a16="http://schemas.microsoft.com/office/drawing/2014/main" id="{1CFCD8E4-0BEA-4213-B246-EEF658AE7EB8}"/>
+              </a:ext>
+            </a:extLst>
+          </p:cNvPr>
+          <p:cNvSpPr txBox="1"/>
+          <p:nvPr/>
+        </p:nvSpPr>
+        <p:spPr>
+          <a:xfrm>
+            <a:off x="609600" y="965200"/>
+            <a:ext cx="5486400" cy="246221"/>
+          </a:xfrm>
+          <a:prstGeom prst="rect">
+            <a:avLst/>
+          </a:prstGeom>
+          <a:noFill/>
+        </p:spPr>
+        <p:txBody>
+          <a:bodyPr vertOverflow="overflow" vert="horz" wrap="square" rtlCol="0" anchor="t">
+            <a:spAutoFit/>
+          </a:bodyPr>
+          <a:lstStyle/>
+          <a:p>
+            <a:pPr marL="0" indent="0">
+              <a:buNone/>
+            </a:pPr>
+            <a:r>
+              <a:rPr lang="en-AU" sz="1000" b="1" kern="0" spc="300" dirty="0">
+                <a:solidFill>
+                  <a:srgbClr val="4A5A6E"/>
+                </a:solidFill>
+                <a:latin typeface="Inter"/>
+              </a:rPr>
+              <a:t>§ END OF DECK</a:t>
+            </a:r>
+          </a:p>
+        </p:txBody>
+      </p:sp>
+      <p:sp>
+        <p:nvSpPr>
+          <p:cNvPr id="20" name="TextBox 19">
+            <a:extLst>
+              <a:ext uri="{FF2B5EF4-FFF2-40B4-BE49-F238E27FC236}">
+                <a16:creationId xmlns:a16="http://schemas.microsoft.com/office/drawing/2014/main" id="{A6B25A88-6D13-4953-8B10-E7DCB215C59D}"/>
+              </a:ext>
+            </a:extLst>
+          </p:cNvPr>
+          <p:cNvSpPr txBox="1"/>
+          <p:nvPr/>
+        </p:nvSpPr>
+        <p:spPr>
+          <a:xfrm>
+            <a:off x="609600" y="1905000"/>
+            <a:ext cx="10972800" cy="1143000"/>
+          </a:xfrm>
+          <a:prstGeom prst="rect">
+            <a:avLst/>
+          </a:prstGeom>
+          <a:noFill/>
+        </p:spPr>
+        <p:txBody>
+          <a:bodyPr vertOverflow="overflow" vert="horz" wrap="square" rtlCol="0" anchor="t">
+            <a:spAutoFit/>
+          </a:bodyPr>
+          <a:lstStyle/>
+          <a:p>
+            <a:pPr marL="0" indent="0">
+              <a:buNone/>
+            </a:pPr>
+            <a:r>
+              <a:rPr lang="en-AU" sz="6600" b="1" i="1" dirty="0">
+                <a:solidFill>
+                  <a:srgbClr val="11304E"/>
+                </a:solidFill>
+                <a:latin typeface="Montserrat"/>
+              </a:rPr>
+              <a:t>Thank you</a:t>
+            </a:r>
+            <a:r>
+              <a:rPr lang="en-AU" sz="6600" b="1" i="1" dirty="0">
+                <a:solidFill>
+                  <a:srgbClr val="2BA39B"/>
+                </a:solidFill>
+                <a:latin typeface="Montserrat"/>
+              </a:rPr>
+              <a:t>.</a:t>
+            </a:r>
+          </a:p>
+        </p:txBody>
+      </p:sp>
+      <p:sp>
+        <p:nvSpPr>
+          <p:cNvPr id="21" name="TextBox 20">
+            <a:extLst>
+              <a:ext uri="{FF2B5EF4-FFF2-40B4-BE49-F238E27FC236}">
+                <a16:creationId xmlns:a16="http://schemas.microsoft.com/office/drawing/2014/main" id="{73517F3F-F4A2-40ED-89DE-56679DC060BD}"/>
+              </a:ext>
+            </a:extLst>
+          </p:cNvPr>
+          <p:cNvSpPr txBox="1"/>
+          <p:nvPr/>
+        </p:nvSpPr>
+        <p:spPr>
+          <a:xfrm>
+            <a:off x="609600" y="3048000"/>
+            <a:ext cx="10972800" cy="461665"/>
+          </a:xfrm>
+          <a:prstGeom prst="rect">
+            <a:avLst/>
+          </a:prstGeom>
+          <a:noFill/>
+        </p:spPr>
+        <p:txBody>
+          <a:bodyPr vertOverflow="overflow" vert="horz" wrap="square" rtlCol="0" anchor="t">
+            <a:spAutoFit/>
+          </a:bodyPr>
+          <a:lstStyle/>
+          <a:p>
+            <a:pPr marL="0" indent="0">
+              <a:buNone/>
+            </a:pPr>
+            <a:r>
+              <a:rPr lang="en-AU" sz="2400" dirty="0">
+                <a:solidFill>
+                  <a:srgbClr val="4A5A6E"/>
+                </a:solidFill>
+                <a:latin typeface="Inter"/>
+              </a:rPr>
+              <a:t>Happy to take your questions.</a:t>
+            </a:r>
+          </a:p>
+        </p:txBody>
+      </p:sp>
+      <p:sp>
+        <p:nvSpPr>
+          <p:cNvPr id="29" name="TextBox 28">
+            <a:extLst>
+              <a:ext uri="{FF2B5EF4-FFF2-40B4-BE49-F238E27FC236}">
+                <a16:creationId xmlns:a16="http://schemas.microsoft.com/office/drawing/2014/main" id="{97975F96-61AB-40B7-A2FE-DDCCEB778F57}"/>
+              </a:ext>
+            </a:extLst>
+          </p:cNvPr>
+          <p:cNvSpPr txBox="1"/>
+          <p:nvPr/>
+        </p:nvSpPr>
+        <p:spPr>
+          <a:xfrm>
+            <a:off x="736600" y="6489700"/>
+            <a:ext cx="7315200" cy="230832"/>
+          </a:xfrm>
+          <a:prstGeom prst="rect">
+            <a:avLst/>
+          </a:prstGeom>
+          <a:noFill/>
+        </p:spPr>
+        <p:txBody>
+          <a:bodyPr vertOverflow="overflow" vert="horz" wrap="square" rtlCol="0" anchor="t">
+            <a:spAutoFit/>
+          </a:bodyPr>
+          <a:lstStyle/>
+          <a:p>
+            <a:pPr marL="0" indent="0">
+              <a:buNone/>
+            </a:pPr>
+            <a:r>
+              <a:rPr lang="en-AU" sz="900" kern="0" spc="200" dirty="0">
+                <a:solidFill>
+                  <a:srgbClr val="4A5A6E"/>
+                </a:solidFill>
+                <a:latin typeface="Inter"/>
+              </a:rPr>
+              <a:t>DVN AT3 · UTS MDSI · AUTUMN 2026</a:t>
+            </a:r>
+          </a:p>
+        </p:txBody>
+      </p:sp>
+      <p:sp>
+        <p:nvSpPr>
+          <p:cNvPr id="30" name="Oval 29">
+            <a:extLst>
+              <a:ext uri="{FF2B5EF4-FFF2-40B4-BE49-F238E27FC236}">
+                <a16:creationId xmlns:a16="http://schemas.microsoft.com/office/drawing/2014/main" id="{3CD94C86-BD44-4149-A3F2-C34AAD18E612}"/>
+              </a:ext>
+            </a:extLst>
+          </p:cNvPr>
+          <p:cNvSpPr/>
+          <p:nvPr/>
+        </p:nvSpPr>
+        <p:spPr>
+          <a:xfrm>
+            <a:off x="609600" y="6578600"/>
+            <a:ext cx="50800" cy="50800"/>
+          </a:xfrm>
+          <a:prstGeom prst="ellipse">
+            <a:avLst/>
+          </a:prstGeom>
+          <a:solidFill>
+            <a:srgbClr val="2BA39B"/>
+          </a:solidFill>
+          <a:ln w="12700" cap="flat" cmpd="sng" algn="ctr">
+            <a:noFill/>
+            <a:prstDash val="solid"/>
+            <a:miter lim="800000"/>
+          </a:ln>
+        </p:spPr>
+        <p:style>
+          <a:lnRef idx="2">
+            <a:schemeClr val="accent1">
+              <a:shade val="15000"/>
+            </a:schemeClr>
+          </a:lnRef>
+          <a:fillRef idx="1">
+            <a:schemeClr val="accent1"/>
+          </a:fillRef>
+          <a:effectRef idx="0">
+            <a:schemeClr val="accent1"/>
+          </a:effectRef>
+          <a:fontRef idx="minor">
+            <a:schemeClr val="lt1"/>
+          </a:fontRef>
+        </p:style>
+        <p:txBody>
+          <a:bodyPr vertOverflow="clip" horzOverflow="clip" rtlCol="0" anchor="t"/>
+          <a:lstStyle/>
+          <a:p>
+            <a:pPr algn="l"/>
+            <a:endParaRPr lang="en-AU"/>
+          </a:p>
+        </p:txBody>
+      </p:sp>
+      <p:sp>
+        <p:nvSpPr>
+          <p:cNvPr id="31" name="TextBox 30">
+            <a:extLst>
+              <a:ext uri="{FF2B5EF4-FFF2-40B4-BE49-F238E27FC236}">
+                <a16:creationId xmlns:a16="http://schemas.microsoft.com/office/drawing/2014/main" id="{396C3721-FEFB-4D42-87D9-2C4B0F04A8B4}"/>
+              </a:ext>
+            </a:extLst>
+          </p:cNvPr>
+          <p:cNvSpPr txBox="1"/>
+          <p:nvPr/>
+        </p:nvSpPr>
+        <p:spPr>
+          <a:xfrm>
+            <a:off x="10210800" y="6489700"/>
+            <a:ext cx="1371600" cy="230832"/>
+          </a:xfrm>
+          <a:prstGeom prst="rect">
+            <a:avLst/>
+          </a:prstGeom>
+          <a:noFill/>
+        </p:spPr>
+        <p:txBody>
+          <a:bodyPr vertOverflow="overflow" vert="horz" wrap="square" rtlCol="0" anchor="t">
+            <a:spAutoFit/>
+          </a:bodyPr>
+          <a:lstStyle/>
+          <a:p>
+            <a:pPr marL="0" indent="0" algn="r">
+              <a:buNone/>
+            </a:pPr>
+            <a:r>
+              <a:rPr lang="en-AU" sz="900" kern="0" spc="200" dirty="0">
+                <a:solidFill>
+                  <a:srgbClr val="4A5A6E"/>
+                </a:solidFill>
+                <a:latin typeface="Inter"/>
+              </a:rPr>
+              <a:t>end</a:t>
+            </a:r>
+          </a:p>
+        </p:txBody>
+      </p:sp>
+    </p:spTree>
+    <p:extLst>
+      <p:ext uri="{BB962C8B-B14F-4D97-AF65-F5344CB8AC3E}">
+        <p14:creationId xmlns:p14="http://schemas.microsoft.com/office/powerpoint/2010/main" val="1311235166"/>
       </p:ext>
     </p:extLst>
   </p:cSld>
@@ -12807,6 +13429,28 @@
           </a:p>
         </p:txBody>
       </p:sp>
+      <p:graphicFrame>
+        <p:nvGraphicFramePr>
+          <p:cNvPr id="25" name="Chart 0">
+            <a:extLst>
+              <a:ext uri="{FF2B5EF4-FFF2-40B4-BE49-F238E27FC236}">
+                <a16:creationId xmlns:a16="http://schemas.microsoft.com/office/drawing/2014/main" id="{3661C1A1-3FCB-2097-91D2-FBB5A880AA19}"/>
+              </a:ext>
+            </a:extLst>
+          </p:cNvPr>
+          <p:cNvGraphicFramePr/>
+          <p:nvPr/>
+        </p:nvGraphicFramePr>
+        <p:xfrm>
+          <a:off x="765048" y="2758440"/>
+          <a:ext cx="10966399" cy="2971800"/>
+        </p:xfrm>
+        <a:graphic>
+          <a:graphicData uri="http://schemas.openxmlformats.org/drawingml/2006/chart">
+            <c:chart xmlns:c="http://schemas.openxmlformats.org/drawingml/2006/chart" xmlns:r="http://schemas.openxmlformats.org/officeDocument/2006/relationships" r:id="rId4"/>
+          </a:graphicData>
+        </a:graphic>
+      </p:graphicFrame>
     </p:spTree>
     <p:extLst>
       <p:ext uri="{BB962C8B-B14F-4D97-AF65-F5344CB8AC3E}">
@@ -13094,7 +13738,7 @@
           <a:bodyPr/>
           <a:lstStyle/>
           <a:p>
-            <a:endParaRPr lang="en-AU"/>
+            <a:endParaRPr lang="en-AU" dirty="0"/>
           </a:p>
         </p:txBody>
       </p:sp>
@@ -13175,7 +13819,7 @@
         </p:nvSpPr>
         <p:spPr>
           <a:xfrm>
-            <a:off x="886968" y="3154680"/>
+            <a:off x="950976" y="3530600"/>
             <a:ext cx="4888840" cy="320040"/>
           </a:xfrm>
           <a:prstGeom prst="rect">
@@ -13294,7 +13938,7 @@
           <a:bodyPr/>
           <a:lstStyle/>
           <a:p>
-            <a:endParaRPr lang="en-AU"/>
+            <a:endParaRPr lang="en-AU" dirty="0"/>
           </a:p>
         </p:txBody>
       </p:sp>
@@ -13388,19 +14032,15 @@
           <a:bodyPr wrap="square" lIns="0" tIns="0" rIns="0" bIns="0" rtlCol="0" anchor="ctr"/>
           <a:lstStyle/>
           <a:p>
-            <a:pPr marL="0" indent="0">
-              <a:buNone/>
-            </a:pPr>
-            <a:r>
-              <a:rPr lang="en-US" sz="1800" b="1" dirty="0">
+            <a:r>
+              <a:rPr lang="en-US" b="1" dirty="0">
                 <a:solidFill>
                   <a:srgbClr val="11304E"/>
                 </a:solidFill>
-                <a:latin typeface="Inter"/>
               </a:rPr>
               <a:t>Where the beds went</a:t>
             </a:r>
-            <a:endParaRPr lang="en-US" sz="1800" dirty="0"/>
+            <a:endParaRPr lang="en-US" dirty="0"/>
           </a:p>
         </p:txBody>
       </p:sp>
@@ -14831,6 +15471,54 @@
           </a:p>
         </p:txBody>
       </p:sp>
+      <p:sp>
+        <p:nvSpPr>
+          <p:cNvPr id="62" name="TextBox 61">
+            <a:extLst>
+              <a:ext uri="{FF2B5EF4-FFF2-40B4-BE49-F238E27FC236}">
+                <a16:creationId xmlns:a16="http://schemas.microsoft.com/office/drawing/2014/main" id="{0D14536E-4066-1023-8822-E9109B23B1FF}"/>
+              </a:ext>
+            </a:extLst>
+          </p:cNvPr>
+          <p:cNvSpPr txBox="1"/>
+          <p:nvPr/>
+        </p:nvSpPr>
+        <p:spPr>
+          <a:xfrm>
+            <a:off x="795832" y="3112254"/>
+            <a:ext cx="6097604" cy="369332"/>
+          </a:xfrm>
+          <a:prstGeom prst="rect">
+            <a:avLst/>
+          </a:prstGeom>
+          <a:noFill/>
+        </p:spPr>
+        <p:txBody>
+          <a:bodyPr wrap="square">
+            <a:spAutoFit/>
+          </a:bodyPr>
+          <a:lstStyle/>
+          <a:p>
+            <a:r>
+              <a:rPr lang="en-US" b="1" dirty="0">
+                <a:solidFill>
+                  <a:srgbClr val="11304E"/>
+                </a:solidFill>
+              </a:rPr>
+              <a:t>Where the </a:t>
+            </a:r>
+            <a:r>
+              <a:rPr lang="vi-VN" b="1" dirty="0">
+                <a:solidFill>
+                  <a:srgbClr val="11304E"/>
+                </a:solidFill>
+              </a:rPr>
+              <a:t>need is</a:t>
+            </a:r>
+            <a:endParaRPr lang="en-US" dirty="0"/>
+          </a:p>
+        </p:txBody>
+      </p:sp>
     </p:spTree>
     <p:extLst>
       <p:ext uri="{BB962C8B-B14F-4D97-AF65-F5344CB8AC3E}">
@@ -15232,7 +15920,7 @@
                 </a:solidFill>
                 <a:latin typeface="Inter"/>
               </a:rPr>
-              <a:t>Sidebar rewrites every chart and callout across all 5 chapters.</a:t>
+              <a:t>Sidebar rewrites every chart and callout across</a:t>
             </a:r>
             <a:endParaRPr lang="en-US" sz="1200" dirty="0"/>
           </a:p>
@@ -15247,7 +15935,7 @@
         <p:spPr>
           <a:xfrm>
             <a:off x="6233008" y="2788920"/>
-            <a:ext cx="5346040" cy="1645920"/>
+            <a:ext cx="4178300" cy="1645920"/>
           </a:xfrm>
           <a:prstGeom prst="rect">
             <a:avLst/>
@@ -15348,7 +16036,7 @@
         <p:spPr>
           <a:xfrm>
             <a:off x="7467448" y="3063240"/>
-            <a:ext cx="3928720" cy="457200"/>
+            <a:ext cx="2755900" cy="457200"/>
           </a:xfrm>
           <a:prstGeom prst="rect">
             <a:avLst/>
@@ -15385,7 +16073,7 @@
         <p:spPr>
           <a:xfrm>
             <a:off x="7467448" y="3566160"/>
-            <a:ext cx="3928720" cy="731520"/>
+            <a:ext cx="2755900" cy="731520"/>
           </a:xfrm>
           <a:prstGeom prst="rect">
             <a:avLst/>
@@ -15597,7 +16285,7 @@
         <p:spPr>
           <a:xfrm>
             <a:off x="6233008" y="4663440"/>
-            <a:ext cx="5346040" cy="1645920"/>
+            <a:ext cx="4178300" cy="1645920"/>
           </a:xfrm>
           <a:prstGeom prst="rect">
             <a:avLst/>
@@ -15698,7 +16386,7 @@
         <p:spPr>
           <a:xfrm>
             <a:off x="7467448" y="4937760"/>
-            <a:ext cx="3928720" cy="457200"/>
+            <a:ext cx="2755900" cy="457200"/>
           </a:xfrm>
           <a:prstGeom prst="rect">
             <a:avLst/>
@@ -15735,7 +16423,7 @@
         <p:spPr>
           <a:xfrm>
             <a:off x="7467448" y="5440680"/>
-            <a:ext cx="3928720" cy="731520"/>
+            <a:ext cx="2755900" cy="731520"/>
           </a:xfrm>
           <a:prstGeom prst="rect">
             <a:avLst/>
@@ -15869,10 +16557,83 @@
           </a:p>
         </p:txBody>
       </p:sp>
+      <p:pic>
+        <p:nvPicPr>
+          <p:cNvPr id="30" name="Picture 29">
+            <a:extLst>
+              <a:ext uri="{FF2B5EF4-FFF2-40B4-BE49-F238E27FC236}">
+                <a16:creationId xmlns:a16="http://schemas.microsoft.com/office/drawing/2014/main" id="{645FD8DE-7207-B38F-9C1D-879C1AF4C441}"/>
+              </a:ext>
+            </a:extLst>
+          </p:cNvPr>
+          <p:cNvPicPr>
+            <a:picLocks noChangeAspect="1"/>
+          </p:cNvPicPr>
+          <p:nvPr/>
+        </p:nvPicPr>
+        <p:blipFill>
+          <a:blip r:embed="rId3"/>
+          <a:stretch>
+            <a:fillRect/>
+          </a:stretch>
+        </p:blipFill>
+        <p:spPr>
+          <a:xfrm>
+            <a:off x="10566400" y="3175000"/>
+            <a:ext cx="965200" cy="965200"/>
+          </a:xfrm>
+          <a:prstGeom prst="rect">
+            <a:avLst/>
+          </a:prstGeom>
+        </p:spPr>
+      </p:pic>
+      <p:sp>
+        <p:nvSpPr>
+          <p:cNvPr id="31" name="TextBox 30">
+            <a:extLst>
+              <a:ext uri="{FF2B5EF4-FFF2-40B4-BE49-F238E27FC236}">
+                <a16:creationId xmlns:a16="http://schemas.microsoft.com/office/drawing/2014/main" id="{E4AA6E1E-BFCD-4C47-ABEF-08E8BF54639E}"/>
+              </a:ext>
+            </a:extLst>
+          </p:cNvPr>
+          <p:cNvSpPr txBox="1"/>
+          <p:nvPr/>
+        </p:nvSpPr>
+        <p:spPr>
+          <a:xfrm>
+            <a:off x="10414000" y="4216400"/>
+            <a:ext cx="1270000" cy="203200"/>
+          </a:xfrm>
+          <a:prstGeom prst="rect">
+            <a:avLst/>
+          </a:prstGeom>
+          <a:noFill/>
+        </p:spPr>
+        <p:txBody>
+          <a:bodyPr vertOverflow="overflow" vert="horz" wrap="square" rtlCol="0" anchor="t">
+            <a:spAutoFit/>
+          </a:bodyPr>
+          <a:lstStyle/>
+          <a:p>
+            <a:pPr marL="0" indent="0" algn="ctr">
+              <a:buNone/>
+            </a:pPr>
+            <a:r>
+              <a:rPr lang="en-AU" sz="1000" b="1" kern="0" spc="200" dirty="0">
+                <a:solidFill>
+                  <a:srgbClr val="2BA39B"/>
+                </a:solidFill>
+                <a:latin typeface="Inter"/>
+              </a:rPr>
+              <a:t>SCAN · LIVE STREAMLIT</a:t>
+            </a:r>
+          </a:p>
+        </p:txBody>
+      </p:sp>
     </p:spTree>
     <p:extLst>
       <p:ext uri="{BB962C8B-B14F-4D97-AF65-F5344CB8AC3E}">
-        <p14:creationId xmlns:p14="http://schemas.microsoft.com/office/powerpoint/2010/main" val="3063924028"/>
+        <p14:creationId xmlns:p14="http://schemas.microsoft.com/office/powerpoint/2010/main" val="3268042608"/>
       </p:ext>
     </p:extLst>
   </p:cSld>

</xml_diff>